<commit_message>
PPTX with full graphic slides
</commit_message>
<xml_diff>
--- a/accesly-pitch.pptx
+++ b/accesly-pitch.pptx
@@ -3087,14 +3087,6 @@
 <file path=ppt/slides/slide1.xml><?xml version="1.0" encoding="utf-8"?>
 <p:sld xmlns:a="http://schemas.openxmlformats.org/drawingml/2006/main" xmlns:p="http://schemas.openxmlformats.org/presentationml/2006/main" xmlns:r="http://schemas.openxmlformats.org/officeDocument/2006/relationships">
   <p:cSld>
-    <p:bg>
-      <p:bgPr>
-        <a:solidFill>
-          <a:srgbClr val="000000"/>
-        </a:solidFill>
-        <a:effectLst/>
-      </p:bgPr>
-    </p:bg>
     <p:spTree>
       <p:nvGrpSpPr>
         <p:cNvPr id="1" name=""/>
@@ -3102,82 +3094,30 @@
         <p:nvPr/>
       </p:nvGrpSpPr>
       <p:grpSpPr/>
-      <p:sp>
-        <p:nvSpPr>
-          <p:cNvPr id="2" name="TextBox 1"/>
-          <p:cNvSpPr txBox="1"/>
+      <p:pic>
+        <p:nvPicPr>
+          <p:cNvPr id="2" name="Picture 1" descr="slide_1.png"/>
+          <p:cNvPicPr>
+            <a:picLocks noChangeAspect="1"/>
+          </p:cNvPicPr>
           <p:nvPr/>
-        </p:nvSpPr>
+        </p:nvPicPr>
+        <p:blipFill>
+          <a:blip r:embed="rId2"/>
+          <a:stretch>
+            <a:fillRect/>
+          </a:stretch>
+        </p:blipFill>
         <p:spPr>
           <a:xfrm>
-            <a:off x="457200" y="2286000"/>
-            <a:ext cx="10972800" cy="1371600"/>
+            <a:off x="0" y="0"/>
+            <a:ext cx="12191695" cy="6858000"/>
           </a:xfrm>
           <a:prstGeom prst="rect">
             <a:avLst/>
           </a:prstGeom>
-          <a:noFill/>
         </p:spPr>
-        <p:txBody>
-          <a:bodyPr wrap="square">
-            <a:spAutoFit/>
-          </a:bodyPr>
-          <a:lstStyle/>
-          <a:p>
-            <a:pPr>
-              <a:defRPr sz="7200" b="1">
-                <a:solidFill>
-                  <a:srgbClr val="8B6CE7"/>
-                </a:solidFill>
-                <a:latin typeface="Arial"/>
-              </a:defRPr>
-            </a:pPr>
-            <a:r>
-              <a:t>Accesly</a:t>
-            </a:r>
-          </a:p>
-        </p:txBody>
-      </p:sp>
-      <p:sp>
-        <p:nvSpPr>
-          <p:cNvPr id="3" name="TextBox 2"/>
-          <p:cNvSpPr txBox="1"/>
-          <p:nvPr/>
-        </p:nvSpPr>
-        <p:spPr>
-          <a:xfrm>
-            <a:off x="457200" y="3657600"/>
-            <a:ext cx="10972800" cy="914400"/>
-          </a:xfrm>
-          <a:prstGeom prst="rect">
-            <a:avLst/>
-          </a:prstGeom>
-          <a:noFill/>
-        </p:spPr>
-        <p:txBody>
-          <a:bodyPr wrap="square">
-            <a:spAutoFit/>
-          </a:bodyPr>
-          <a:lstStyle/>
-          <a:p>
-            <a:pPr>
-              <a:defRPr sz="3200" b="1">
-                <a:solidFill>
-                  <a:srgbClr val="FFFFFF"/>
-                </a:solidFill>
-                <a:latin typeface="Arial"/>
-              </a:defRPr>
-            </a:pPr>
-            <a:r>
-              <a:t>Focus on your value proposition.</a:t>
-            </a:r>
-            <a:br/>
-            <a:r>
-              <a:t>We handle the friction.</a:t>
-            </a:r>
-          </a:p>
-        </p:txBody>
-      </p:sp>
+      </p:pic>
     </p:spTree>
   </p:cSld>
   <p:clrMapOvr>
@@ -3189,14 +3129,6 @@
 <file path=ppt/slides/slide2.xml><?xml version="1.0" encoding="utf-8"?>
 <p:sld xmlns:a="http://schemas.openxmlformats.org/drawingml/2006/main" xmlns:p="http://schemas.openxmlformats.org/presentationml/2006/main" xmlns:r="http://schemas.openxmlformats.org/officeDocument/2006/relationships">
   <p:cSld>
-    <p:bg>
-      <p:bgPr>
-        <a:solidFill>
-          <a:srgbClr val="000000"/>
-        </a:solidFill>
-        <a:effectLst/>
-      </p:bgPr>
-    </p:bg>
     <p:spTree>
       <p:nvGrpSpPr>
         <p:cNvPr id="1" name=""/>
@@ -3204,402 +3136,30 @@
         <p:nvPr/>
       </p:nvGrpSpPr>
       <p:grpSpPr/>
-      <p:sp>
-        <p:nvSpPr>
-          <p:cNvPr id="2" name="TextBox 1"/>
-          <p:cNvSpPr txBox="1"/>
+      <p:pic>
+        <p:nvPicPr>
+          <p:cNvPr id="2" name="Picture 1" descr="slide_2.png"/>
+          <p:cNvPicPr>
+            <a:picLocks noChangeAspect="1"/>
+          </p:cNvPicPr>
           <p:nvPr/>
-        </p:nvSpPr>
+        </p:nvPicPr>
+        <p:blipFill>
+          <a:blip r:embed="rId2"/>
+          <a:stretch>
+            <a:fillRect/>
+          </a:stretch>
+        </p:blipFill>
         <p:spPr>
           <a:xfrm>
-            <a:off x="457200" y="457200"/>
-            <a:ext cx="2743200" cy="457200"/>
+            <a:off x="0" y="0"/>
+            <a:ext cx="12191695" cy="6858000"/>
           </a:xfrm>
           <a:prstGeom prst="rect">
             <a:avLst/>
           </a:prstGeom>
-          <a:noFill/>
         </p:spPr>
-        <p:txBody>
-          <a:bodyPr wrap="square">
-            <a:spAutoFit/>
-          </a:bodyPr>
-          <a:lstStyle/>
-          <a:p>
-            <a:pPr>
-              <a:defRPr sz="1200" b="1">
-                <a:solidFill>
-                  <a:srgbClr val="8B6CE7"/>
-                </a:solidFill>
-                <a:latin typeface="Arial"/>
-              </a:defRPr>
-            </a:pPr>
-            <a:r>
-              <a:t>THE PROBLEM</a:t>
-            </a:r>
-          </a:p>
-        </p:txBody>
-      </p:sp>
-      <p:sp>
-        <p:nvSpPr>
-          <p:cNvPr id="3" name="TextBox 2"/>
-          <p:cNvSpPr txBox="1"/>
-          <p:nvPr/>
-        </p:nvSpPr>
-        <p:spPr>
-          <a:xfrm>
-            <a:off x="457200" y="1097280"/>
-            <a:ext cx="9144000" cy="1371600"/>
-          </a:xfrm>
-          <a:prstGeom prst="rect">
-            <a:avLst/>
-          </a:prstGeom>
-          <a:noFill/>
-        </p:spPr>
-        <p:txBody>
-          <a:bodyPr wrap="square">
-            <a:spAutoFit/>
-          </a:bodyPr>
-          <a:lstStyle/>
-          <a:p>
-            <a:pPr>
-              <a:defRPr sz="3600" b="1">
-                <a:solidFill>
-                  <a:srgbClr val="FFFFFF"/>
-                </a:solidFill>
-                <a:latin typeface="Arial"/>
-              </a:defRPr>
-            </a:pPr>
-            <a:r>
-              <a:t>Web3 security puts all responsibility on the user and users fail.</a:t>
-            </a:r>
-          </a:p>
-        </p:txBody>
-      </p:sp>
-      <p:sp>
-        <p:nvSpPr>
-          <p:cNvPr id="4" name="TextBox 3"/>
-          <p:cNvSpPr txBox="1"/>
-          <p:nvPr/>
-        </p:nvSpPr>
-        <p:spPr>
-          <a:xfrm>
-            <a:off x="457200" y="3200400"/>
-            <a:ext cx="3200400" cy="914400"/>
-          </a:xfrm>
-          <a:prstGeom prst="rect">
-            <a:avLst/>
-          </a:prstGeom>
-          <a:noFill/>
-        </p:spPr>
-        <p:txBody>
-          <a:bodyPr wrap="square">
-            <a:spAutoFit/>
-          </a:bodyPr>
-          <a:lstStyle/>
-          <a:p>
-            <a:pPr>
-              <a:defRPr sz="4800" b="1">
-                <a:solidFill>
-                  <a:srgbClr val="8B6CE7"/>
-                </a:solidFill>
-                <a:latin typeface="Arial"/>
-              </a:defRPr>
-            </a:pPr>
-            <a:r>
-              <a:t>$1.7B</a:t>
-            </a:r>
-          </a:p>
-        </p:txBody>
-      </p:sp>
-      <p:sp>
-        <p:nvSpPr>
-          <p:cNvPr id="5" name="TextBox 4"/>
-          <p:cNvSpPr txBox="1"/>
-          <p:nvPr/>
-        </p:nvSpPr>
-        <p:spPr>
-          <a:xfrm>
-            <a:off x="457200" y="4114800"/>
-            <a:ext cx="3200400" cy="457200"/>
-          </a:xfrm>
-          <a:prstGeom prst="rect">
-            <a:avLst/>
-          </a:prstGeom>
-          <a:noFill/>
-        </p:spPr>
-        <p:txBody>
-          <a:bodyPr wrap="square">
-            <a:spAutoFit/>
-          </a:bodyPr>
-          <a:lstStyle/>
-          <a:p>
-            <a:pPr>
-              <a:defRPr sz="1400" b="0">
-                <a:solidFill>
-                  <a:srgbClr val="D4CED9"/>
-                </a:solidFill>
-                <a:latin typeface="Arial"/>
-              </a:defRPr>
-            </a:pPr>
-            <a:r>
-              <a:t>Lost to key compromises</a:t>
-            </a:r>
-          </a:p>
-        </p:txBody>
-      </p:sp>
-      <p:sp>
-        <p:nvSpPr>
-          <p:cNvPr id="6" name="TextBox 5"/>
-          <p:cNvSpPr txBox="1"/>
-          <p:nvPr/>
-        </p:nvSpPr>
-        <p:spPr>
-          <a:xfrm>
-            <a:off x="457200" y="4572000"/>
-            <a:ext cx="3200400" cy="457200"/>
-          </a:xfrm>
-          <a:prstGeom prst="rect">
-            <a:avLst/>
-          </a:prstGeom>
-          <a:noFill/>
-        </p:spPr>
-        <p:txBody>
-          <a:bodyPr wrap="square">
-            <a:spAutoFit/>
-          </a:bodyPr>
-          <a:lstStyle/>
-          <a:p>
-            <a:pPr>
-              <a:defRPr sz="1000" b="0">
-                <a:solidFill>
-                  <a:srgbClr val="6B5F78"/>
-                </a:solidFill>
-                <a:latin typeface="Arial"/>
-              </a:defRPr>
-            </a:pPr>
-            <a:r>
-              <a:t>CertiK, H1 2025</a:t>
-            </a:r>
-          </a:p>
-        </p:txBody>
-      </p:sp>
-      <p:sp>
-        <p:nvSpPr>
-          <p:cNvPr id="7" name="TextBox 6"/>
-          <p:cNvSpPr txBox="1"/>
-          <p:nvPr/>
-        </p:nvSpPr>
-        <p:spPr>
-          <a:xfrm>
-            <a:off x="4114800" y="3200400"/>
-            <a:ext cx="3200400" cy="914400"/>
-          </a:xfrm>
-          <a:prstGeom prst="rect">
-            <a:avLst/>
-          </a:prstGeom>
-          <a:noFill/>
-        </p:spPr>
-        <p:txBody>
-          <a:bodyPr wrap="square">
-            <a:spAutoFit/>
-          </a:bodyPr>
-          <a:lstStyle/>
-          <a:p>
-            <a:pPr>
-              <a:defRPr sz="4800" b="1">
-                <a:solidFill>
-                  <a:srgbClr val="FF8FAB"/>
-                </a:solidFill>
-                <a:latin typeface="Arial"/>
-              </a:defRPr>
-            </a:pPr>
-            <a:r>
-              <a:t>69%</a:t>
-            </a:r>
-          </a:p>
-        </p:txBody>
-      </p:sp>
-      <p:sp>
-        <p:nvSpPr>
-          <p:cNvPr id="8" name="TextBox 7"/>
-          <p:cNvSpPr txBox="1"/>
-          <p:nvPr/>
-        </p:nvSpPr>
-        <p:spPr>
-          <a:xfrm>
-            <a:off x="4114800" y="4114800"/>
-            <a:ext cx="3200400" cy="457200"/>
-          </a:xfrm>
-          <a:prstGeom prst="rect">
-            <a:avLst/>
-          </a:prstGeom>
-          <a:noFill/>
-        </p:spPr>
-        <p:txBody>
-          <a:bodyPr wrap="square">
-            <a:spAutoFit/>
-          </a:bodyPr>
-          <a:lstStyle/>
-          <a:p>
-            <a:pPr>
-              <a:defRPr sz="1400" b="0">
-                <a:solidFill>
-                  <a:srgbClr val="D4CED9"/>
-                </a:solidFill>
-                <a:latin typeface="Arial"/>
-              </a:defRPr>
-            </a:pPr>
-            <a:r>
-              <a:t>From wallet compromises</a:t>
-            </a:r>
-          </a:p>
-        </p:txBody>
-      </p:sp>
-      <p:sp>
-        <p:nvSpPr>
-          <p:cNvPr id="9" name="TextBox 8"/>
-          <p:cNvSpPr txBox="1"/>
-          <p:nvPr/>
-        </p:nvSpPr>
-        <p:spPr>
-          <a:xfrm>
-            <a:off x="4114800" y="4572000"/>
-            <a:ext cx="3200400" cy="457200"/>
-          </a:xfrm>
-          <a:prstGeom prst="rect">
-            <a:avLst/>
-          </a:prstGeom>
-          <a:noFill/>
-        </p:spPr>
-        <p:txBody>
-          <a:bodyPr wrap="square">
-            <a:spAutoFit/>
-          </a:bodyPr>
-          <a:lstStyle/>
-          <a:p>
-            <a:pPr>
-              <a:defRPr sz="1000" b="0">
-                <a:solidFill>
-                  <a:srgbClr val="6B5F78"/>
-                </a:solidFill>
-                <a:latin typeface="Arial"/>
-              </a:defRPr>
-            </a:pPr>
-            <a:r>
-              <a:t>CertiK, H1 2025</a:t>
-            </a:r>
-          </a:p>
-        </p:txBody>
-      </p:sp>
-      <p:sp>
-        <p:nvSpPr>
-          <p:cNvPr id="10" name="TextBox 9"/>
-          <p:cNvSpPr txBox="1"/>
-          <p:nvPr/>
-        </p:nvSpPr>
-        <p:spPr>
-          <a:xfrm>
-            <a:off x="7772400" y="3200400"/>
-            <a:ext cx="3200400" cy="914400"/>
-          </a:xfrm>
-          <a:prstGeom prst="rect">
-            <a:avLst/>
-          </a:prstGeom>
-          <a:noFill/>
-        </p:spPr>
-        <p:txBody>
-          <a:bodyPr wrap="square">
-            <a:spAutoFit/>
-          </a:bodyPr>
-          <a:lstStyle/>
-          <a:p>
-            <a:pPr>
-              <a:defRPr sz="4800" b="1">
-                <a:solidFill>
-                  <a:srgbClr val="45C9A8"/>
-                </a:solidFill>
-                <a:latin typeface="Arial"/>
-              </a:defRPr>
-            </a:pPr>
-            <a:r>
-              <a:t>3.7M</a:t>
-            </a:r>
-          </a:p>
-        </p:txBody>
-      </p:sp>
-      <p:sp>
-        <p:nvSpPr>
-          <p:cNvPr id="11" name="TextBox 10"/>
-          <p:cNvSpPr txBox="1"/>
-          <p:nvPr/>
-        </p:nvSpPr>
-        <p:spPr>
-          <a:xfrm>
-            <a:off x="7772400" y="4114800"/>
-            <a:ext cx="3200400" cy="457200"/>
-          </a:xfrm>
-          <a:prstGeom prst="rect">
-            <a:avLst/>
-          </a:prstGeom>
-          <a:noFill/>
-        </p:spPr>
-        <p:txBody>
-          <a:bodyPr wrap="square">
-            <a:spAutoFit/>
-          </a:bodyPr>
-          <a:lstStyle/>
-          <a:p>
-            <a:pPr>
-              <a:defRPr sz="1400" b="0">
-                <a:solidFill>
-                  <a:srgbClr val="D4CED9"/>
-                </a:solidFill>
-                <a:latin typeface="Arial"/>
-              </a:defRPr>
-            </a:pPr>
-            <a:r>
-              <a:t>BTC lost to seed phrases</a:t>
-            </a:r>
-          </a:p>
-        </p:txBody>
-      </p:sp>
-      <p:sp>
-        <p:nvSpPr>
-          <p:cNvPr id="12" name="TextBox 11"/>
-          <p:cNvSpPr txBox="1"/>
-          <p:nvPr/>
-        </p:nvSpPr>
-        <p:spPr>
-          <a:xfrm>
-            <a:off x="7772400" y="4572000"/>
-            <a:ext cx="3200400" cy="457200"/>
-          </a:xfrm>
-          <a:prstGeom prst="rect">
-            <a:avLst/>
-          </a:prstGeom>
-          <a:noFill/>
-        </p:spPr>
-        <p:txBody>
-          <a:bodyPr wrap="square">
-            <a:spAutoFit/>
-          </a:bodyPr>
-          <a:lstStyle/>
-          <a:p>
-            <a:pPr>
-              <a:defRPr sz="1000" b="0">
-                <a:solidFill>
-                  <a:srgbClr val="6B5F78"/>
-                </a:solidFill>
-                <a:latin typeface="Arial"/>
-              </a:defRPr>
-            </a:pPr>
-            <a:r>
-              <a:t>Ledger, 2025</a:t>
-            </a:r>
-          </a:p>
-        </p:txBody>
-      </p:sp>
+      </p:pic>
     </p:spTree>
   </p:cSld>
   <p:clrMapOvr>
@@ -3611,14 +3171,6 @@
 <file path=ppt/slides/slide3.xml><?xml version="1.0" encoding="utf-8"?>
 <p:sld xmlns:a="http://schemas.openxmlformats.org/drawingml/2006/main" xmlns:p="http://schemas.openxmlformats.org/presentationml/2006/main" xmlns:r="http://schemas.openxmlformats.org/officeDocument/2006/relationships">
   <p:cSld>
-    <p:bg>
-      <p:bgPr>
-        <a:solidFill>
-          <a:srgbClr val="000000"/>
-        </a:solidFill>
-        <a:effectLst/>
-      </p:bgPr>
-    </p:bg>
     <p:spTree>
       <p:nvGrpSpPr>
         <p:cNvPr id="1" name=""/>
@@ -3626,207 +3178,30 @@
         <p:nvPr/>
       </p:nvGrpSpPr>
       <p:grpSpPr/>
-      <p:sp>
-        <p:nvSpPr>
-          <p:cNvPr id="2" name="TextBox 1"/>
-          <p:cNvSpPr txBox="1"/>
+      <p:pic>
+        <p:nvPicPr>
+          <p:cNvPr id="2" name="Picture 1" descr="slide_3.png"/>
+          <p:cNvPicPr>
+            <a:picLocks noChangeAspect="1"/>
+          </p:cNvPicPr>
           <p:nvPr/>
-        </p:nvSpPr>
+        </p:nvPicPr>
+        <p:blipFill>
+          <a:blip r:embed="rId2"/>
+          <a:stretch>
+            <a:fillRect/>
+          </a:stretch>
+        </p:blipFill>
         <p:spPr>
           <a:xfrm>
-            <a:off x="457200" y="457200"/>
-            <a:ext cx="2743200" cy="457200"/>
+            <a:off x="0" y="0"/>
+            <a:ext cx="12191695" cy="6858000"/>
           </a:xfrm>
           <a:prstGeom prst="rect">
             <a:avLst/>
           </a:prstGeom>
-          <a:noFill/>
         </p:spPr>
-        <p:txBody>
-          <a:bodyPr wrap="square">
-            <a:spAutoFit/>
-          </a:bodyPr>
-          <a:lstStyle/>
-          <a:p>
-            <a:pPr>
-              <a:defRPr sz="1200" b="1">
-                <a:solidFill>
-                  <a:srgbClr val="45C9A8"/>
-                </a:solidFill>
-                <a:latin typeface="Arial"/>
-              </a:defRPr>
-            </a:pPr>
-            <a:r>
-              <a:t>THE SOLUTION</a:t>
-            </a:r>
-          </a:p>
-        </p:txBody>
-      </p:sp>
-      <p:sp>
-        <p:nvSpPr>
-          <p:cNvPr id="3" name="TextBox 2"/>
-          <p:cNvSpPr txBox="1"/>
-          <p:nvPr/>
-        </p:nvSpPr>
-        <p:spPr>
-          <a:xfrm>
-            <a:off x="457200" y="1097280"/>
-            <a:ext cx="9144000" cy="914400"/>
-          </a:xfrm>
-          <a:prstGeom prst="rect">
-            <a:avLst/>
-          </a:prstGeom>
-          <a:noFill/>
-        </p:spPr>
-        <p:txBody>
-          <a:bodyPr wrap="square">
-            <a:spAutoFit/>
-          </a:bodyPr>
-          <a:lstStyle/>
-          <a:p>
-            <a:pPr>
-              <a:defRPr sz="3600" b="1">
-                <a:solidFill>
-                  <a:srgbClr val="FFFFFF"/>
-                </a:solidFill>
-                <a:latin typeface="Arial"/>
-              </a:defRPr>
-            </a:pPr>
-            <a:r>
-              <a:t>One click. 3 seconds. Your wallet is ready.</a:t>
-            </a:r>
-          </a:p>
-        </p:txBody>
-      </p:sp>
-      <p:sp>
-        <p:nvSpPr>
-          <p:cNvPr id="4" name="TextBox 3"/>
-          <p:cNvSpPr txBox="1"/>
-          <p:nvPr/>
-        </p:nvSpPr>
-        <p:spPr>
-          <a:xfrm>
-            <a:off x="457200" y="2286000"/>
-            <a:ext cx="10972800" cy="3657600"/>
-          </a:xfrm>
-          <a:prstGeom prst="rect">
-            <a:avLst/>
-          </a:prstGeom>
-          <a:noFill/>
-        </p:spPr>
-        <p:txBody>
-          <a:bodyPr wrap="square">
-            <a:spAutoFit/>
-          </a:bodyPr>
-          <a:lstStyle/>
-          <a:p>
-            <a:br/>
-            <a:pPr>
-              <a:defRPr sz="1800" b="0">
-                <a:solidFill>
-                  <a:srgbClr val="D4CED9"/>
-                </a:solidFill>
-                <a:latin typeface="Arial"/>
-              </a:defRPr>
-            </a:pPr>
-            <a:r>
-              <a:t>    1️⃣ SIGN IN</a:t>
-            </a:r>
-            <a:br/>
-            <a:r>
-              <a:t>    Sign in with Google or Email</a:t>
-            </a:r>
-            <a:br/>
-            <a:r>
-              <a:t>    </a:t>
-            </a:r>
-            <a:br/>
-            <a:r>
-              <a:t>    ➡️</a:t>
-            </a:r>
-            <a:br/>
-            <a:r>
-              <a:t>    </a:t>
-            </a:r>
-            <a:br/>
-            <a:r>
-              <a:t>    2️⃣ WALLET CREATED</a:t>
-            </a:r>
-            <a:br/>
-            <a:r>
-              <a:t>    Your Stellar wallet is ready</a:t>
-            </a:r>
-            <a:br/>
-            <a:r>
-              <a:t>    Public Key: GAXK...7F2M</a:t>
-            </a:r>
-            <a:br/>
-            <a:r>
-              <a:t>    </a:t>
-            </a:r>
-            <a:br/>
-            <a:r>
-              <a:t>    ➡️</a:t>
-            </a:r>
-            <a:br/>
-            <a:r>
-              <a:t>    </a:t>
-            </a:r>
-            <a:br/>
-            <a:r>
-              <a:t>    3️⃣ READY TO TRANSACT</a:t>
-            </a:r>
-            <a:br/>
-            <a:r>
-              <a:t>    Balance: 0.00 XLM</a:t>
-            </a:r>
-            <a:br/>
-            <a:r>
-              <a:t>    Send | Receive</a:t>
-            </a:r>
-            <a:br/>
-            <a:r>
-              <a:t>    </a:t>
-            </a:r>
-          </a:p>
-        </p:txBody>
-      </p:sp>
-      <p:sp>
-        <p:nvSpPr>
-          <p:cNvPr id="5" name="TextBox 4"/>
-          <p:cNvSpPr txBox="1"/>
-          <p:nvPr/>
-        </p:nvSpPr>
-        <p:spPr>
-          <a:xfrm>
-            <a:off x="4572000" y="5943600"/>
-            <a:ext cx="3657600" cy="457200"/>
-          </a:xfrm>
-          <a:prstGeom prst="rect">
-            <a:avLst/>
-          </a:prstGeom>
-          <a:noFill/>
-        </p:spPr>
-        <p:txBody>
-          <a:bodyPr wrap="square">
-            <a:spAutoFit/>
-          </a:bodyPr>
-          <a:lstStyle/>
-          <a:p>
-            <a:pPr>
-              <a:defRPr sz="1400" b="0">
-                <a:solidFill>
-                  <a:srgbClr val="9E95A7"/>
-                </a:solidFill>
-                <a:latin typeface="Arial"/>
-              </a:defRPr>
-            </a:pPr>
-            <a:r>
-              <a:t>Powered by Etherfuse</a:t>
-            </a:r>
-          </a:p>
-        </p:txBody>
-      </p:sp>
+      </p:pic>
     </p:spTree>
   </p:cSld>
   <p:clrMapOvr>
@@ -3838,14 +3213,6 @@
 <file path=ppt/slides/slide4.xml><?xml version="1.0" encoding="utf-8"?>
 <p:sld xmlns:a="http://schemas.openxmlformats.org/drawingml/2006/main" xmlns:p="http://schemas.openxmlformats.org/presentationml/2006/main" xmlns:r="http://schemas.openxmlformats.org/officeDocument/2006/relationships">
   <p:cSld>
-    <p:bg>
-      <p:bgPr>
-        <a:solidFill>
-          <a:srgbClr val="000000"/>
-        </a:solidFill>
-        <a:effectLst/>
-      </p:bgPr>
-    </p:bg>
     <p:spTree>
       <p:nvGrpSpPr>
         <p:cNvPr id="1" name=""/>
@@ -3853,114 +3220,30 @@
         <p:nvPr/>
       </p:nvGrpSpPr>
       <p:grpSpPr/>
-      <p:sp>
-        <p:nvSpPr>
-          <p:cNvPr id="2" name="TextBox 1"/>
-          <p:cNvSpPr txBox="1"/>
+      <p:pic>
+        <p:nvPicPr>
+          <p:cNvPr id="2" name="Picture 1" descr="slide_4.png"/>
+          <p:cNvPicPr>
+            <a:picLocks noChangeAspect="1"/>
+          </p:cNvPicPr>
           <p:nvPr/>
-        </p:nvSpPr>
+        </p:nvPicPr>
+        <p:blipFill>
+          <a:blip r:embed="rId2"/>
+          <a:stretch>
+            <a:fillRect/>
+          </a:stretch>
+        </p:blipFill>
         <p:spPr>
           <a:xfrm>
-            <a:off x="457200" y="457200"/>
-            <a:ext cx="2743200" cy="457200"/>
+            <a:off x="0" y="0"/>
+            <a:ext cx="12191695" cy="6858000"/>
           </a:xfrm>
           <a:prstGeom prst="rect">
             <a:avLst/>
           </a:prstGeom>
-          <a:noFill/>
         </p:spPr>
-        <p:txBody>
-          <a:bodyPr wrap="square">
-            <a:spAutoFit/>
-          </a:bodyPr>
-          <a:lstStyle/>
-          <a:p>
-            <a:pPr>
-              <a:defRPr sz="1200" b="1">
-                <a:solidFill>
-                  <a:srgbClr val="8B6CE7"/>
-                </a:solidFill>
-                <a:latin typeface="Arial"/>
-              </a:defRPr>
-            </a:pPr>
-            <a:r>
-              <a:t>LIVE DEMO</a:t>
-            </a:r>
-          </a:p>
-        </p:txBody>
-      </p:sp>
-      <p:sp>
-        <p:nvSpPr>
-          <p:cNvPr id="3" name="TextBox 2"/>
-          <p:cNvSpPr txBox="1"/>
-          <p:nvPr/>
-        </p:nvSpPr>
-        <p:spPr>
-          <a:xfrm>
-            <a:off x="1828800" y="2743200"/>
-            <a:ext cx="8229600" cy="1371600"/>
-          </a:xfrm>
-          <a:prstGeom prst="rect">
-            <a:avLst/>
-          </a:prstGeom>
-          <a:noFill/>
-        </p:spPr>
-        <p:txBody>
-          <a:bodyPr wrap="square">
-            <a:spAutoFit/>
-          </a:bodyPr>
-          <a:lstStyle/>
-          <a:p>
-            <a:pPr>
-              <a:defRPr sz="4800" b="1">
-                <a:solidFill>
-                  <a:srgbClr val="FFFFFF"/>
-                </a:solidFill>
-                <a:latin typeface="Arial"/>
-              </a:defRPr>
-            </a:pPr>
-            <a:r>
-              <a:t>See it in action.</a:t>
-            </a:r>
-          </a:p>
-        </p:txBody>
-      </p:sp>
-      <p:sp>
-        <p:nvSpPr>
-          <p:cNvPr id="4" name="TextBox 3"/>
-          <p:cNvSpPr txBox="1"/>
-          <p:nvPr/>
-        </p:nvSpPr>
-        <p:spPr>
-          <a:xfrm>
-            <a:off x="2743200" y="4572000"/>
-            <a:ext cx="6400800" cy="457200"/>
-          </a:xfrm>
-          <a:prstGeom prst="rect">
-            <a:avLst/>
-          </a:prstGeom>
-          <a:noFill/>
-        </p:spPr>
-        <p:txBody>
-          <a:bodyPr wrap="square">
-            <a:spAutoFit/>
-          </a:bodyPr>
-          <a:lstStyle/>
-          <a:p>
-            <a:pPr>
-              <a:defRPr sz="1800" b="0">
-                <a:solidFill>
-                  <a:srgbClr val="9E95A7"/>
-                </a:solidFill>
-                <a:latin typeface="Arial"/>
-              </a:defRPr>
-            </a:pPr>
-            <a:r>
-              <a:t>[Split screen: User view | Developer view]</a:t>
-            </a:r>
-          </a:p>
-        </p:txBody>
-      </p:sp>
+      </p:pic>
     </p:spTree>
   </p:cSld>
   <p:clrMapOvr>
@@ -3972,14 +3255,6 @@
 <file path=ppt/slides/slide5.xml><?xml version="1.0" encoding="utf-8"?>
 <p:sld xmlns:a="http://schemas.openxmlformats.org/drawingml/2006/main" xmlns:p="http://schemas.openxmlformats.org/presentationml/2006/main" xmlns:r="http://schemas.openxmlformats.org/officeDocument/2006/relationships">
   <p:cSld>
-    <p:bg>
-      <p:bgPr>
-        <a:solidFill>
-          <a:srgbClr val="000000"/>
-        </a:solidFill>
-        <a:effectLst/>
-      </p:bgPr>
-    </p:bg>
     <p:spTree>
       <p:nvGrpSpPr>
         <p:cNvPr id="1" name=""/>
@@ -3987,582 +3262,30 @@
         <p:nvPr/>
       </p:nvGrpSpPr>
       <p:grpSpPr/>
-      <p:sp>
-        <p:nvSpPr>
-          <p:cNvPr id="2" name="TextBox 1"/>
-          <p:cNvSpPr txBox="1"/>
+      <p:pic>
+        <p:nvPicPr>
+          <p:cNvPr id="2" name="Picture 1" descr="slide_5.png"/>
+          <p:cNvPicPr>
+            <a:picLocks noChangeAspect="1"/>
+          </p:cNvPicPr>
           <p:nvPr/>
-        </p:nvSpPr>
+        </p:nvPicPr>
+        <p:blipFill>
+          <a:blip r:embed="rId2"/>
+          <a:stretch>
+            <a:fillRect/>
+          </a:stretch>
+        </p:blipFill>
         <p:spPr>
           <a:xfrm>
-            <a:off x="457200" y="457200"/>
-            <a:ext cx="2743200" cy="457200"/>
+            <a:off x="0" y="0"/>
+            <a:ext cx="12191695" cy="6858000"/>
           </a:xfrm>
           <a:prstGeom prst="rect">
             <a:avLst/>
           </a:prstGeom>
-          <a:noFill/>
         </p:spPr>
-        <p:txBody>
-          <a:bodyPr wrap="square">
-            <a:spAutoFit/>
-          </a:bodyPr>
-          <a:lstStyle/>
-          <a:p>
-            <a:pPr>
-              <a:defRPr sz="1200" b="1">
-                <a:solidFill>
-                  <a:srgbClr val="45C9A8"/>
-                </a:solidFill>
-                <a:latin typeface="Arial"/>
-              </a:defRPr>
-            </a:pPr>
-            <a:r>
-              <a:t>TRACTION</a:t>
-            </a:r>
-          </a:p>
-        </p:txBody>
-      </p:sp>
-      <p:sp>
-        <p:nvSpPr>
-          <p:cNvPr id="3" name="TextBox 2"/>
-          <p:cNvSpPr txBox="1"/>
-          <p:nvPr/>
-        </p:nvSpPr>
-        <p:spPr>
-          <a:xfrm>
-            <a:off x="457200" y="1097280"/>
-            <a:ext cx="5486400" cy="914400"/>
-          </a:xfrm>
-          <a:prstGeom prst="rect">
-            <a:avLst/>
-          </a:prstGeom>
-          <a:noFill/>
-        </p:spPr>
-        <p:txBody>
-          <a:bodyPr wrap="square">
-            <a:spAutoFit/>
-          </a:bodyPr>
-          <a:lstStyle/>
-          <a:p>
-            <a:pPr>
-              <a:defRPr sz="3600" b="1">
-                <a:solidFill>
-                  <a:srgbClr val="FFFFFF"/>
-                </a:solidFill>
-                <a:latin typeface="Arial"/>
-              </a:defRPr>
-            </a:pPr>
-            <a:r>
-              <a:t>Growing on Stellar</a:t>
-            </a:r>
-          </a:p>
-        </p:txBody>
-      </p:sp>
-      <p:sp>
-        <p:nvSpPr>
-          <p:cNvPr id="4" name="TextBox 3"/>
-          <p:cNvSpPr txBox="1"/>
-          <p:nvPr/>
-        </p:nvSpPr>
-        <p:spPr>
-          <a:xfrm>
-            <a:off x="457200" y="1645920"/>
-            <a:ext cx="5486400" cy="457200"/>
-          </a:xfrm>
-          <a:prstGeom prst="rect">
-            <a:avLst/>
-          </a:prstGeom>
-          <a:noFill/>
-        </p:spPr>
-        <p:txBody>
-          <a:bodyPr wrap="square">
-            <a:spAutoFit/>
-          </a:bodyPr>
-          <a:lstStyle/>
-          <a:p>
-            <a:pPr>
-              <a:defRPr sz="1400" b="0">
-                <a:solidFill>
-                  <a:srgbClr val="9E95A7"/>
-                </a:solidFill>
-                <a:latin typeface="Arial"/>
-              </a:defRPr>
-            </a:pPr>
-            <a:r>
-              <a:t>Key metrics and milestones</a:t>
-            </a:r>
-          </a:p>
-        </p:txBody>
-      </p:sp>
-      <p:sp>
-        <p:nvSpPr>
-          <p:cNvPr id="5" name="TextBox 4"/>
-          <p:cNvSpPr txBox="1"/>
-          <p:nvPr/>
-        </p:nvSpPr>
-        <p:spPr>
-          <a:xfrm>
-            <a:off x="457200" y="2286000"/>
-            <a:ext cx="10972800" cy="1371600"/>
-          </a:xfrm>
-          <a:prstGeom prst="rect">
-            <a:avLst/>
-          </a:prstGeom>
-          <a:noFill/>
-        </p:spPr>
-        <p:txBody>
-          <a:bodyPr wrap="square">
-            <a:spAutoFit/>
-          </a:bodyPr>
-          <a:lstStyle/>
-          <a:p>
-            <a:pPr>
-              <a:defRPr sz="1800" b="0">
-                <a:solidFill>
-                  <a:srgbClr val="D4CED9"/>
-                </a:solidFill>
-                <a:latin typeface="Arial"/>
-              </a:defRPr>
-            </a:pPr>
-            <a:r>
-              <a:t>📈 Wallets Created - Real-time growth chart from Feb 10 to Mar 22</a:t>
-            </a:r>
-          </a:p>
-        </p:txBody>
-      </p:sp>
-      <p:sp>
-        <p:nvSpPr>
-          <p:cNvPr id="6" name="TextBox 5"/>
-          <p:cNvSpPr txBox="1"/>
-          <p:nvPr/>
-        </p:nvSpPr>
-        <p:spPr>
-          <a:xfrm>
-            <a:off x="457200" y="4114800"/>
-            <a:ext cx="2560320" cy="731520"/>
-          </a:xfrm>
-          <a:prstGeom prst="rect">
-            <a:avLst/>
-          </a:prstGeom>
-          <a:noFill/>
-        </p:spPr>
-        <p:txBody>
-          <a:bodyPr wrap="square">
-            <a:spAutoFit/>
-          </a:bodyPr>
-          <a:lstStyle/>
-          <a:p>
-            <a:pPr>
-              <a:defRPr sz="3600" b="1">
-                <a:solidFill>
-                  <a:srgbClr val="FFFFFF"/>
-                </a:solidFill>
-                <a:latin typeface="Arial"/>
-              </a:defRPr>
-            </a:pPr>
-            <a:r>
-              <a:t>112</a:t>
-            </a:r>
-          </a:p>
-        </p:txBody>
-      </p:sp>
-      <p:sp>
-        <p:nvSpPr>
-          <p:cNvPr id="7" name="TextBox 6"/>
-          <p:cNvSpPr txBox="1"/>
-          <p:nvPr/>
-        </p:nvSpPr>
-        <p:spPr>
-          <a:xfrm>
-            <a:off x="457200" y="4846320"/>
-            <a:ext cx="2560320" cy="365760"/>
-          </a:xfrm>
-          <a:prstGeom prst="rect">
-            <a:avLst/>
-          </a:prstGeom>
-          <a:noFill/>
-        </p:spPr>
-        <p:txBody>
-          <a:bodyPr wrap="square">
-            <a:spAutoFit/>
-          </a:bodyPr>
-          <a:lstStyle/>
-          <a:p>
-            <a:pPr>
-              <a:defRPr sz="1200" b="1">
-                <a:solidFill>
-                  <a:srgbClr val="D4CED9"/>
-                </a:solidFill>
-                <a:latin typeface="Arial"/>
-              </a:defRPr>
-            </a:pPr>
-            <a:r>
-              <a:t>Wallets created</a:t>
-            </a:r>
-          </a:p>
-        </p:txBody>
-      </p:sp>
-      <p:sp>
-        <p:nvSpPr>
-          <p:cNvPr id="8" name="TextBox 7"/>
-          <p:cNvSpPr txBox="1"/>
-          <p:nvPr/>
-        </p:nvSpPr>
-        <p:spPr>
-          <a:xfrm>
-            <a:off x="457200" y="5212080"/>
-            <a:ext cx="2560320" cy="365760"/>
-          </a:xfrm>
-          <a:prstGeom prst="rect">
-            <a:avLst/>
-          </a:prstGeom>
-          <a:noFill/>
-        </p:spPr>
-        <p:txBody>
-          <a:bodyPr wrap="square">
-            <a:spAutoFit/>
-          </a:bodyPr>
-          <a:lstStyle/>
-          <a:p>
-            <a:pPr>
-              <a:defRPr sz="1000" b="0">
-                <a:solidFill>
-                  <a:srgbClr val="9E95A7"/>
-                </a:solidFill>
-                <a:latin typeface="Arial"/>
-              </a:defRPr>
-            </a:pPr>
-            <a:r>
-              <a:t>Real-time from Stellar</a:t>
-            </a:r>
-          </a:p>
-        </p:txBody>
-      </p:sp>
-      <p:sp>
-        <p:nvSpPr>
-          <p:cNvPr id="9" name="TextBox 8"/>
-          <p:cNvSpPr txBox="1"/>
-          <p:nvPr/>
-        </p:nvSpPr>
-        <p:spPr>
-          <a:xfrm>
-            <a:off x="3291840" y="4114800"/>
-            <a:ext cx="2560320" cy="731520"/>
-          </a:xfrm>
-          <a:prstGeom prst="rect">
-            <a:avLst/>
-          </a:prstGeom>
-          <a:noFill/>
-        </p:spPr>
-        <p:txBody>
-          <a:bodyPr wrap="square">
-            <a:spAutoFit/>
-          </a:bodyPr>
-          <a:lstStyle/>
-          <a:p>
-            <a:pPr>
-              <a:defRPr sz="3600" b="1">
-                <a:solidFill>
-                  <a:srgbClr val="FFFFFF"/>
-                </a:solidFill>
-                <a:latin typeface="Arial"/>
-              </a:defRPr>
-            </a:pPr>
-            <a:r>
-              <a:t>3s</a:t>
-            </a:r>
-          </a:p>
-        </p:txBody>
-      </p:sp>
-      <p:sp>
-        <p:nvSpPr>
-          <p:cNvPr id="10" name="TextBox 9"/>
-          <p:cNvSpPr txBox="1"/>
-          <p:nvPr/>
-        </p:nvSpPr>
-        <p:spPr>
-          <a:xfrm>
-            <a:off x="3291840" y="4846320"/>
-            <a:ext cx="2560320" cy="365760"/>
-          </a:xfrm>
-          <a:prstGeom prst="rect">
-            <a:avLst/>
-          </a:prstGeom>
-          <a:noFill/>
-        </p:spPr>
-        <p:txBody>
-          <a:bodyPr wrap="square">
-            <a:spAutoFit/>
-          </a:bodyPr>
-          <a:lstStyle/>
-          <a:p>
-            <a:pPr>
-              <a:defRPr sz="1200" b="1">
-                <a:solidFill>
-                  <a:srgbClr val="D4CED9"/>
-                </a:solidFill>
-                <a:latin typeface="Arial"/>
-              </a:defRPr>
-            </a:pPr>
-            <a:r>
-              <a:t>Onboarding time</a:t>
-            </a:r>
-          </a:p>
-        </p:txBody>
-      </p:sp>
-      <p:sp>
-        <p:nvSpPr>
-          <p:cNvPr id="11" name="TextBox 10"/>
-          <p:cNvSpPr txBox="1"/>
-          <p:nvPr/>
-        </p:nvSpPr>
-        <p:spPr>
-          <a:xfrm>
-            <a:off x="3291840" y="5212080"/>
-            <a:ext cx="2560320" cy="365760"/>
-          </a:xfrm>
-          <a:prstGeom prst="rect">
-            <a:avLst/>
-          </a:prstGeom>
-          <a:noFill/>
-        </p:spPr>
-        <p:txBody>
-          <a:bodyPr wrap="square">
-            <a:spAutoFit/>
-          </a:bodyPr>
-          <a:lstStyle/>
-          <a:p>
-            <a:pPr>
-              <a:defRPr sz="1000" b="0">
-                <a:solidFill>
-                  <a:srgbClr val="9E95A7"/>
-                </a:solidFill>
-                <a:latin typeface="Arial"/>
-              </a:defRPr>
-            </a:pPr>
-            <a:r>
-              <a:t>Average user flow</a:t>
-            </a:r>
-          </a:p>
-        </p:txBody>
-      </p:sp>
-      <p:sp>
-        <p:nvSpPr>
-          <p:cNvPr id="12" name="TextBox 11"/>
-          <p:cNvSpPr txBox="1"/>
-          <p:nvPr/>
-        </p:nvSpPr>
-        <p:spPr>
-          <a:xfrm>
-            <a:off x="6126480" y="4114800"/>
-            <a:ext cx="2560320" cy="731520"/>
-          </a:xfrm>
-          <a:prstGeom prst="rect">
-            <a:avLst/>
-          </a:prstGeom>
-          <a:noFill/>
-        </p:spPr>
-        <p:txBody>
-          <a:bodyPr wrap="square">
-            <a:spAutoFit/>
-          </a:bodyPr>
-          <a:lstStyle/>
-          <a:p>
-            <a:pPr>
-              <a:defRPr sz="3600" b="1">
-                <a:solidFill>
-                  <a:srgbClr val="FFFFFF"/>
-                </a:solidFill>
-                <a:latin typeface="Arial"/>
-              </a:defRPr>
-            </a:pPr>
-            <a:r>
-              <a:t>396</a:t>
-            </a:r>
-          </a:p>
-        </p:txBody>
-      </p:sp>
-      <p:sp>
-        <p:nvSpPr>
-          <p:cNvPr id="13" name="TextBox 12"/>
-          <p:cNvSpPr txBox="1"/>
-          <p:nvPr/>
-        </p:nvSpPr>
-        <p:spPr>
-          <a:xfrm>
-            <a:off x="6126480" y="4846320"/>
-            <a:ext cx="2560320" cy="365760"/>
-          </a:xfrm>
-          <a:prstGeom prst="rect">
-            <a:avLst/>
-          </a:prstGeom>
-          <a:noFill/>
-        </p:spPr>
-        <p:txBody>
-          <a:bodyPr wrap="square">
-            <a:spAutoFit/>
-          </a:bodyPr>
-          <a:lstStyle/>
-          <a:p>
-            <a:pPr>
-              <a:defRPr sz="1200" b="1">
-                <a:solidFill>
-                  <a:srgbClr val="D4CED9"/>
-                </a:solidFill>
-                <a:latin typeface="Arial"/>
-              </a:defRPr>
-            </a:pPr>
-            <a:r>
-              <a:t>npm Downloads</a:t>
-            </a:r>
-          </a:p>
-        </p:txBody>
-      </p:sp>
-      <p:sp>
-        <p:nvSpPr>
-          <p:cNvPr id="14" name="TextBox 13"/>
-          <p:cNvSpPr txBox="1"/>
-          <p:nvPr/>
-        </p:nvSpPr>
-        <p:spPr>
-          <a:xfrm>
-            <a:off x="6126480" y="5212080"/>
-            <a:ext cx="2560320" cy="365760"/>
-          </a:xfrm>
-          <a:prstGeom prst="rect">
-            <a:avLst/>
-          </a:prstGeom>
-          <a:noFill/>
-        </p:spPr>
-        <p:txBody>
-          <a:bodyPr wrap="square">
-            <a:spAutoFit/>
-          </a:bodyPr>
-          <a:lstStyle/>
-          <a:p>
-            <a:pPr>
-              <a:defRPr sz="1000" b="0">
-                <a:solidFill>
-                  <a:srgbClr val="9E95A7"/>
-                </a:solidFill>
-                <a:latin typeface="Arial"/>
-              </a:defRPr>
-            </a:pPr>
-            <a:r>
-              <a:t>First week</a:t>
-            </a:r>
-          </a:p>
-        </p:txBody>
-      </p:sp>
-      <p:sp>
-        <p:nvSpPr>
-          <p:cNvPr id="15" name="TextBox 14"/>
-          <p:cNvSpPr txBox="1"/>
-          <p:nvPr/>
-        </p:nvSpPr>
-        <p:spPr>
-          <a:xfrm>
-            <a:off x="8961120" y="4114800"/>
-            <a:ext cx="2560320" cy="731520"/>
-          </a:xfrm>
-          <a:prstGeom prst="rect">
-            <a:avLst/>
-          </a:prstGeom>
-          <a:noFill/>
-        </p:spPr>
-        <p:txBody>
-          <a:bodyPr wrap="square">
-            <a:spAutoFit/>
-          </a:bodyPr>
-          <a:lstStyle/>
-          <a:p>
-            <a:pPr>
-              <a:defRPr sz="3600" b="1">
-                <a:solidFill>
-                  <a:srgbClr val="FFFFFF"/>
-                </a:solidFill>
-                <a:latin typeface="Arial"/>
-              </a:defRPr>
-            </a:pPr>
-            <a:r>
-              <a:t>39</a:t>
-            </a:r>
-          </a:p>
-        </p:txBody>
-      </p:sp>
-      <p:sp>
-        <p:nvSpPr>
-          <p:cNvPr id="16" name="TextBox 15"/>
-          <p:cNvSpPr txBox="1"/>
-          <p:nvPr/>
-        </p:nvSpPr>
-        <p:spPr>
-          <a:xfrm>
-            <a:off x="8961120" y="4846320"/>
-            <a:ext cx="2560320" cy="365760"/>
-          </a:xfrm>
-          <a:prstGeom prst="rect">
-            <a:avLst/>
-          </a:prstGeom>
-          <a:noFill/>
-        </p:spPr>
-        <p:txBody>
-          <a:bodyPr wrap="square">
-            <a:spAutoFit/>
-          </a:bodyPr>
-          <a:lstStyle/>
-          <a:p>
-            <a:pPr>
-              <a:defRPr sz="1200" b="1">
-                <a:solidFill>
-                  <a:srgbClr val="D4CED9"/>
-                </a:solidFill>
-                <a:latin typeface="Arial"/>
-              </a:defRPr>
-            </a:pPr>
-            <a:r>
-              <a:t>Active integrations</a:t>
-            </a:r>
-          </a:p>
-        </p:txBody>
-      </p:sp>
-      <p:sp>
-        <p:nvSpPr>
-          <p:cNvPr id="17" name="TextBox 16"/>
-          <p:cNvSpPr txBox="1"/>
-          <p:nvPr/>
-        </p:nvSpPr>
-        <p:spPr>
-          <a:xfrm>
-            <a:off x="8961120" y="5212080"/>
-            <a:ext cx="2560320" cy="365760"/>
-          </a:xfrm>
-          <a:prstGeom prst="rect">
-            <a:avLst/>
-          </a:prstGeom>
-          <a:noFill/>
-        </p:spPr>
-        <p:txBody>
-          <a:bodyPr wrap="square">
-            <a:spAutoFit/>
-          </a:bodyPr>
-          <a:lstStyle/>
-          <a:p>
-            <a:pPr>
-              <a:defRPr sz="1000" b="0">
-                <a:solidFill>
-                  <a:srgbClr val="9E95A7"/>
-                </a:solidFill>
-                <a:latin typeface="Arial"/>
-              </a:defRPr>
-            </a:pPr>
-            <a:r>
-              <a:t>Developer projects</a:t>
-            </a:r>
-          </a:p>
-        </p:txBody>
-      </p:sp>
+      </p:pic>
     </p:spTree>
   </p:cSld>
   <p:clrMapOvr>
@@ -4574,14 +3297,6 @@
 <file path=ppt/slides/slide6.xml><?xml version="1.0" encoding="utf-8"?>
 <p:sld xmlns:a="http://schemas.openxmlformats.org/drawingml/2006/main" xmlns:p="http://schemas.openxmlformats.org/presentationml/2006/main" xmlns:r="http://schemas.openxmlformats.org/officeDocument/2006/relationships">
   <p:cSld>
-    <p:bg>
-      <p:bgPr>
-        <a:solidFill>
-          <a:srgbClr val="000000"/>
-        </a:solidFill>
-        <a:effectLst/>
-      </p:bgPr>
-    </p:bg>
     <p:spTree>
       <p:nvGrpSpPr>
         <p:cNvPr id="1" name=""/>
@@ -4589,534 +3304,30 @@
         <p:nvPr/>
       </p:nvGrpSpPr>
       <p:grpSpPr/>
-      <p:sp>
-        <p:nvSpPr>
-          <p:cNvPr id="2" name="TextBox 1"/>
-          <p:cNvSpPr txBox="1"/>
+      <p:pic>
+        <p:nvPicPr>
+          <p:cNvPr id="2" name="Picture 1" descr="slide_6.png"/>
+          <p:cNvPicPr>
+            <a:picLocks noChangeAspect="1"/>
+          </p:cNvPicPr>
           <p:nvPr/>
-        </p:nvSpPr>
+        </p:nvPicPr>
+        <p:blipFill>
+          <a:blip r:embed="rId2"/>
+          <a:stretch>
+            <a:fillRect/>
+          </a:stretch>
+        </p:blipFill>
         <p:spPr>
           <a:xfrm>
-            <a:off x="457200" y="457200"/>
-            <a:ext cx="2743200" cy="457200"/>
+            <a:off x="0" y="0"/>
+            <a:ext cx="12191695" cy="6858000"/>
           </a:xfrm>
           <a:prstGeom prst="rect">
             <a:avLst/>
           </a:prstGeom>
-          <a:noFill/>
         </p:spPr>
-        <p:txBody>
-          <a:bodyPr wrap="square">
-            <a:spAutoFit/>
-          </a:bodyPr>
-          <a:lstStyle/>
-          <a:p>
-            <a:pPr>
-              <a:defRPr sz="1200" b="1">
-                <a:solidFill>
-                  <a:srgbClr val="8B6CE7"/>
-                </a:solidFill>
-                <a:latin typeface="Arial"/>
-              </a:defRPr>
-            </a:pPr>
-            <a:r>
-              <a:t>ROADMAP</a:t>
-            </a:r>
-          </a:p>
-        </p:txBody>
-      </p:sp>
-      <p:sp>
-        <p:nvSpPr>
-          <p:cNvPr id="3" name="TextBox 2"/>
-          <p:cNvSpPr txBox="1"/>
-          <p:nvPr/>
-        </p:nvSpPr>
-        <p:spPr>
-          <a:xfrm>
-            <a:off x="457200" y="1097280"/>
-            <a:ext cx="9144000" cy="914400"/>
-          </a:xfrm>
-          <a:prstGeom prst="rect">
-            <a:avLst/>
-          </a:prstGeom>
-          <a:noFill/>
-        </p:spPr>
-        <p:txBody>
-          <a:bodyPr wrap="square">
-            <a:spAutoFit/>
-          </a:bodyPr>
-          <a:lstStyle/>
-          <a:p>
-            <a:pPr>
-              <a:defRPr sz="3600" b="1">
-                <a:solidFill>
-                  <a:srgbClr val="FFFFFF"/>
-                </a:solidFill>
-                <a:latin typeface="Arial"/>
-              </a:defRPr>
-            </a:pPr>
-            <a:r>
-              <a:t>From testnet to mainnet in 90 days</a:t>
-            </a:r>
-          </a:p>
-        </p:txBody>
-      </p:sp>
-      <p:sp>
-        <p:nvSpPr>
-          <p:cNvPr id="4" name="TextBox 3"/>
-          <p:cNvSpPr txBox="1"/>
-          <p:nvPr/>
-        </p:nvSpPr>
-        <p:spPr>
-          <a:xfrm>
-            <a:off x="457200" y="2286000"/>
-            <a:ext cx="914400" cy="548640"/>
-          </a:xfrm>
-          <a:prstGeom prst="rect">
-            <a:avLst/>
-          </a:prstGeom>
-          <a:noFill/>
-        </p:spPr>
-        <p:txBody>
-          <a:bodyPr wrap="square">
-            <a:spAutoFit/>
-          </a:bodyPr>
-          <a:lstStyle/>
-          <a:p>
-            <a:pPr>
-              <a:defRPr sz="2400" b="1">
-                <a:solidFill>
-                  <a:srgbClr val="8B6CE7"/>
-                </a:solidFill>
-                <a:latin typeface="Arial"/>
-              </a:defRPr>
-            </a:pPr>
-            <a:r>
-              <a:t>30</a:t>
-            </a:r>
-          </a:p>
-        </p:txBody>
-      </p:sp>
-      <p:sp>
-        <p:nvSpPr>
-          <p:cNvPr id="5" name="TextBox 4"/>
-          <p:cNvSpPr txBox="1"/>
-          <p:nvPr/>
-        </p:nvSpPr>
-        <p:spPr>
-          <a:xfrm>
-            <a:off x="457200" y="2834640"/>
-            <a:ext cx="914400" cy="365760"/>
-          </a:xfrm>
-          <a:prstGeom prst="rect">
-            <a:avLst/>
-          </a:prstGeom>
-          <a:noFill/>
-        </p:spPr>
-        <p:txBody>
-          <a:bodyPr wrap="square">
-            <a:spAutoFit/>
-          </a:bodyPr>
-          <a:lstStyle/>
-          <a:p>
-            <a:pPr>
-              <a:defRPr sz="1200" b="1">
-                <a:solidFill>
-                  <a:srgbClr val="8B6CE7"/>
-                </a:solidFill>
-                <a:latin typeface="Arial"/>
-              </a:defRPr>
-            </a:pPr>
-            <a:r>
-              <a:t>APR</a:t>
-            </a:r>
-          </a:p>
-        </p:txBody>
-      </p:sp>
-      <p:sp>
-        <p:nvSpPr>
-          <p:cNvPr id="6" name="TextBox 5"/>
-          <p:cNvSpPr txBox="1"/>
-          <p:nvPr/>
-        </p:nvSpPr>
-        <p:spPr>
-          <a:xfrm>
-            <a:off x="457200" y="3291840"/>
-            <a:ext cx="3200400" cy="457200"/>
-          </a:xfrm>
-          <a:prstGeom prst="rect">
-            <a:avLst/>
-          </a:prstGeom>
-          <a:noFill/>
-        </p:spPr>
-        <p:txBody>
-          <a:bodyPr wrap="square">
-            <a:spAutoFit/>
-          </a:bodyPr>
-          <a:lstStyle/>
-          <a:p>
-            <a:pPr>
-              <a:defRPr sz="1800" b="1">
-                <a:solidFill>
-                  <a:srgbClr val="8B6CE7"/>
-                </a:solidFill>
-                <a:latin typeface="Arial"/>
-              </a:defRPr>
-            </a:pPr>
-            <a:r>
-              <a:t>Testnet</a:t>
-            </a:r>
-          </a:p>
-        </p:txBody>
-      </p:sp>
-      <p:sp>
-        <p:nvSpPr>
-          <p:cNvPr id="7" name="TextBox 6"/>
-          <p:cNvSpPr txBox="1"/>
-          <p:nvPr/>
-        </p:nvSpPr>
-        <p:spPr>
-          <a:xfrm>
-            <a:off x="457200" y="3840480"/>
-            <a:ext cx="3200400" cy="1828800"/>
-          </a:xfrm>
-          <a:prstGeom prst="rect">
-            <a:avLst/>
-          </a:prstGeom>
-          <a:noFill/>
-        </p:spPr>
-        <p:txBody>
-          <a:bodyPr wrap="square">
-            <a:spAutoFit/>
-          </a:bodyPr>
-          <a:lstStyle/>
-          <a:p>
-            <a:pPr>
-              <a:defRPr sz="1400" b="0">
-                <a:solidFill>
-                  <a:srgbClr val="FFFFFF"/>
-                </a:solidFill>
-                <a:latin typeface="Arial"/>
-              </a:defRPr>
-            </a:pPr>
-            <a:r>
-              <a:t>⚡ MPC wallet infrastructure</a:t>
-            </a:r>
-            <a:br/>
-            <a:r>
-              <a:t>⚡ x402 pay-as-you-use</a:t>
-            </a:r>
-            <a:br/>
-            <a:r>
-              <a:t>⚡ Full testnet deployment</a:t>
-            </a:r>
-          </a:p>
-        </p:txBody>
-      </p:sp>
-      <p:sp>
-        <p:nvSpPr>
-          <p:cNvPr id="8" name="TextBox 7"/>
-          <p:cNvSpPr txBox="1"/>
-          <p:nvPr/>
-        </p:nvSpPr>
-        <p:spPr>
-          <a:xfrm>
-            <a:off x="4297680" y="2286000"/>
-            <a:ext cx="914400" cy="548640"/>
-          </a:xfrm>
-          <a:prstGeom prst="rect">
-            <a:avLst/>
-          </a:prstGeom>
-          <a:noFill/>
-        </p:spPr>
-        <p:txBody>
-          <a:bodyPr wrap="square">
-            <a:spAutoFit/>
-          </a:bodyPr>
-          <a:lstStyle/>
-          <a:p>
-            <a:pPr>
-              <a:defRPr sz="2400" b="1">
-                <a:solidFill>
-                  <a:srgbClr val="45C9A8"/>
-                </a:solidFill>
-                <a:latin typeface="Arial"/>
-              </a:defRPr>
-            </a:pPr>
-            <a:r>
-              <a:t>60</a:t>
-            </a:r>
-          </a:p>
-        </p:txBody>
-      </p:sp>
-      <p:sp>
-        <p:nvSpPr>
-          <p:cNvPr id="9" name="TextBox 8"/>
-          <p:cNvSpPr txBox="1"/>
-          <p:nvPr/>
-        </p:nvSpPr>
-        <p:spPr>
-          <a:xfrm>
-            <a:off x="4297680" y="2834640"/>
-            <a:ext cx="914400" cy="365760"/>
-          </a:xfrm>
-          <a:prstGeom prst="rect">
-            <a:avLst/>
-          </a:prstGeom>
-          <a:noFill/>
-        </p:spPr>
-        <p:txBody>
-          <a:bodyPr wrap="square">
-            <a:spAutoFit/>
-          </a:bodyPr>
-          <a:lstStyle/>
-          <a:p>
-            <a:pPr>
-              <a:defRPr sz="1200" b="1">
-                <a:solidFill>
-                  <a:srgbClr val="45C9A8"/>
-                </a:solidFill>
-                <a:latin typeface="Arial"/>
-              </a:defRPr>
-            </a:pPr>
-            <a:r>
-              <a:t>MAY</a:t>
-            </a:r>
-          </a:p>
-        </p:txBody>
-      </p:sp>
-      <p:sp>
-        <p:nvSpPr>
-          <p:cNvPr id="10" name="TextBox 9"/>
-          <p:cNvSpPr txBox="1"/>
-          <p:nvPr/>
-        </p:nvSpPr>
-        <p:spPr>
-          <a:xfrm>
-            <a:off x="4297680" y="3291840"/>
-            <a:ext cx="3200400" cy="457200"/>
-          </a:xfrm>
-          <a:prstGeom prst="rect">
-            <a:avLst/>
-          </a:prstGeom>
-          <a:noFill/>
-        </p:spPr>
-        <p:txBody>
-          <a:bodyPr wrap="square">
-            <a:spAutoFit/>
-          </a:bodyPr>
-          <a:lstStyle/>
-          <a:p>
-            <a:pPr>
-              <a:defRPr sz="1800" b="1">
-                <a:solidFill>
-                  <a:srgbClr val="45C9A8"/>
-                </a:solidFill>
-                <a:latin typeface="Arial"/>
-              </a:defRPr>
-            </a:pPr>
-            <a:r>
-              <a:t>Mainnet</a:t>
-            </a:r>
-          </a:p>
-        </p:txBody>
-      </p:sp>
-      <p:sp>
-        <p:nvSpPr>
-          <p:cNvPr id="11" name="TextBox 10"/>
-          <p:cNvSpPr txBox="1"/>
-          <p:nvPr/>
-        </p:nvSpPr>
-        <p:spPr>
-          <a:xfrm>
-            <a:off x="4297680" y="3840480"/>
-            <a:ext cx="3200400" cy="1828800"/>
-          </a:xfrm>
-          <a:prstGeom prst="rect">
-            <a:avLst/>
-          </a:prstGeom>
-          <a:noFill/>
-        </p:spPr>
-        <p:txBody>
-          <a:bodyPr wrap="square">
-            <a:spAutoFit/>
-          </a:bodyPr>
-          <a:lstStyle/>
-          <a:p>
-            <a:pPr>
-              <a:defRPr sz="1400" b="0">
-                <a:solidFill>
-                  <a:srgbClr val="FFFFFF"/>
-                </a:solidFill>
-                <a:latin typeface="Arial"/>
-              </a:defRPr>
-            </a:pPr>
-            <a:r>
-              <a:t>✓ Real users, real wallets</a:t>
-            </a:r>
-            <a:br/>
-            <a:r>
-              <a:t>✓ Developer payments live</a:t>
-            </a:r>
-            <a:br/>
-            <a:r>
-              <a:t>✓ Production-grade security</a:t>
-            </a:r>
-          </a:p>
-        </p:txBody>
-      </p:sp>
-      <p:sp>
-        <p:nvSpPr>
-          <p:cNvPr id="12" name="TextBox 11"/>
-          <p:cNvSpPr txBox="1"/>
-          <p:nvPr/>
-        </p:nvSpPr>
-        <p:spPr>
-          <a:xfrm>
-            <a:off x="8138160" y="2286000"/>
-            <a:ext cx="914400" cy="548640"/>
-          </a:xfrm>
-          <a:prstGeom prst="rect">
-            <a:avLst/>
-          </a:prstGeom>
-          <a:noFill/>
-        </p:spPr>
-        <p:txBody>
-          <a:bodyPr wrap="square">
-            <a:spAutoFit/>
-          </a:bodyPr>
-          <a:lstStyle/>
-          <a:p>
-            <a:pPr>
-              <a:defRPr sz="2400" b="1">
-                <a:solidFill>
-                  <a:srgbClr val="FF8FAB"/>
-                </a:solidFill>
-                <a:latin typeface="Arial"/>
-              </a:defRPr>
-            </a:pPr>
-            <a:r>
-              <a:t>90</a:t>
-            </a:r>
-          </a:p>
-        </p:txBody>
-      </p:sp>
-      <p:sp>
-        <p:nvSpPr>
-          <p:cNvPr id="13" name="TextBox 12"/>
-          <p:cNvSpPr txBox="1"/>
-          <p:nvPr/>
-        </p:nvSpPr>
-        <p:spPr>
-          <a:xfrm>
-            <a:off x="8138160" y="2834640"/>
-            <a:ext cx="914400" cy="365760"/>
-          </a:xfrm>
-          <a:prstGeom prst="rect">
-            <a:avLst/>
-          </a:prstGeom>
-          <a:noFill/>
-        </p:spPr>
-        <p:txBody>
-          <a:bodyPr wrap="square">
-            <a:spAutoFit/>
-          </a:bodyPr>
-          <a:lstStyle/>
-          <a:p>
-            <a:pPr>
-              <a:defRPr sz="1200" b="1">
-                <a:solidFill>
-                  <a:srgbClr val="FF8FAB"/>
-                </a:solidFill>
-                <a:latin typeface="Arial"/>
-              </a:defRPr>
-            </a:pPr>
-            <a:r>
-              <a:t>JUN</a:t>
-            </a:r>
-          </a:p>
-        </p:txBody>
-      </p:sp>
-      <p:sp>
-        <p:nvSpPr>
-          <p:cNvPr id="14" name="TextBox 13"/>
-          <p:cNvSpPr txBox="1"/>
-          <p:nvPr/>
-        </p:nvSpPr>
-        <p:spPr>
-          <a:xfrm>
-            <a:off x="8138160" y="3291840"/>
-            <a:ext cx="3200400" cy="457200"/>
-          </a:xfrm>
-          <a:prstGeom prst="rect">
-            <a:avLst/>
-          </a:prstGeom>
-          <a:noFill/>
-        </p:spPr>
-        <p:txBody>
-          <a:bodyPr wrap="square">
-            <a:spAutoFit/>
-          </a:bodyPr>
-          <a:lstStyle/>
-          <a:p>
-            <a:pPr>
-              <a:defRPr sz="1800" b="1">
-                <a:solidFill>
-                  <a:srgbClr val="FF8FAB"/>
-                </a:solidFill>
-                <a:latin typeface="Arial"/>
-              </a:defRPr>
-            </a:pPr>
-            <a:r>
-              <a:t>Scale</a:t>
-            </a:r>
-          </a:p>
-        </p:txBody>
-      </p:sp>
-      <p:sp>
-        <p:nvSpPr>
-          <p:cNvPr id="15" name="TextBox 14"/>
-          <p:cNvSpPr txBox="1"/>
-          <p:nvPr/>
-        </p:nvSpPr>
-        <p:spPr>
-          <a:xfrm>
-            <a:off x="8138160" y="3840480"/>
-            <a:ext cx="3200400" cy="1828800"/>
-          </a:xfrm>
-          <a:prstGeom prst="rect">
-            <a:avLst/>
-          </a:prstGeom>
-          <a:noFill/>
-        </p:spPr>
-        <p:txBody>
-          <a:bodyPr wrap="square">
-            <a:spAutoFit/>
-          </a:bodyPr>
-          <a:lstStyle/>
-          <a:p>
-            <a:pPr>
-              <a:defRPr sz="1400" b="0">
-                <a:solidFill>
-                  <a:srgbClr val="FFFFFF"/>
-                </a:solidFill>
-                <a:latin typeface="Arial"/>
-              </a:defRPr>
-            </a:pPr>
-            <a:r>
-              <a:t>◆ Etherfuse yield in Mexico</a:t>
-            </a:r>
-            <a:br/>
-            <a:r>
-              <a:t>◆ Enterprise migration layer</a:t>
-            </a:r>
-            <a:br/>
-            <a:r>
-              <a:t>◆ EVM↔Stellar bridge scoping</a:t>
-            </a:r>
-          </a:p>
-        </p:txBody>
-      </p:sp>
+      </p:pic>
     </p:spTree>
   </p:cSld>
   <p:clrMapOvr>
@@ -5128,14 +3339,6 @@
 <file path=ppt/slides/slide7.xml><?xml version="1.0" encoding="utf-8"?>
 <p:sld xmlns:a="http://schemas.openxmlformats.org/drawingml/2006/main" xmlns:p="http://schemas.openxmlformats.org/presentationml/2006/main" xmlns:r="http://schemas.openxmlformats.org/officeDocument/2006/relationships">
   <p:cSld>
-    <p:bg>
-      <p:bgPr>
-        <a:solidFill>
-          <a:srgbClr val="000000"/>
-        </a:solidFill>
-        <a:effectLst/>
-      </p:bgPr>
-    </p:bg>
     <p:spTree>
       <p:nvGrpSpPr>
         <p:cNvPr id="1" name=""/>
@@ -5143,186 +3346,30 @@
         <p:nvPr/>
       </p:nvGrpSpPr>
       <p:grpSpPr/>
-      <p:sp>
-        <p:nvSpPr>
-          <p:cNvPr id="2" name="TextBox 1"/>
-          <p:cNvSpPr txBox="1"/>
+      <p:pic>
+        <p:nvPicPr>
+          <p:cNvPr id="2" name="Picture 1" descr="slide_7.png"/>
+          <p:cNvPicPr>
+            <a:picLocks noChangeAspect="1"/>
+          </p:cNvPicPr>
           <p:nvPr/>
-        </p:nvSpPr>
+        </p:nvPicPr>
+        <p:blipFill>
+          <a:blip r:embed="rId2"/>
+          <a:stretch>
+            <a:fillRect/>
+          </a:stretch>
+        </p:blipFill>
         <p:spPr>
           <a:xfrm>
-            <a:off x="457200" y="457200"/>
-            <a:ext cx="2743200" cy="457200"/>
+            <a:off x="0" y="0"/>
+            <a:ext cx="12191695" cy="6858000"/>
           </a:xfrm>
           <a:prstGeom prst="rect">
             <a:avLst/>
           </a:prstGeom>
-          <a:noFill/>
         </p:spPr>
-        <p:txBody>
-          <a:bodyPr wrap="square">
-            <a:spAutoFit/>
-          </a:bodyPr>
-          <a:lstStyle/>
-          <a:p>
-            <a:pPr>
-              <a:defRPr sz="1200" b="1">
-                <a:solidFill>
-                  <a:srgbClr val="8B6CE7"/>
-                </a:solidFill>
-                <a:latin typeface="Arial"/>
-              </a:defRPr>
-            </a:pPr>
-            <a:r>
-              <a:t>ACCESLY</a:t>
-            </a:r>
-          </a:p>
-        </p:txBody>
-      </p:sp>
-      <p:sp>
-        <p:nvSpPr>
-          <p:cNvPr id="3" name="TextBox 2"/>
-          <p:cNvSpPr txBox="1"/>
-          <p:nvPr/>
-        </p:nvSpPr>
-        <p:spPr>
-          <a:xfrm>
-            <a:off x="914400" y="2286000"/>
-            <a:ext cx="10058400" cy="914400"/>
-          </a:xfrm>
-          <a:prstGeom prst="rect">
-            <a:avLst/>
-          </a:prstGeom>
-          <a:noFill/>
-        </p:spPr>
-        <p:txBody>
-          <a:bodyPr wrap="square">
-            <a:spAutoFit/>
-          </a:bodyPr>
-          <a:lstStyle/>
-          <a:p>
-            <a:pPr>
-              <a:defRPr sz="4800" b="1">
-                <a:solidFill>
-                  <a:srgbClr val="FFFFFF"/>
-                </a:solidFill>
-                <a:latin typeface="Arial"/>
-              </a:defRPr>
-            </a:pPr>
-            <a:r>
-              <a:t>Join us. Build with us.</a:t>
-            </a:r>
-          </a:p>
-        </p:txBody>
-      </p:sp>
-      <p:sp>
-        <p:nvSpPr>
-          <p:cNvPr id="4" name="TextBox 3"/>
-          <p:cNvSpPr txBox="1"/>
-          <p:nvPr/>
-        </p:nvSpPr>
-        <p:spPr>
-          <a:xfrm>
-            <a:off x="914400" y="3657600"/>
-            <a:ext cx="10058400" cy="457200"/>
-          </a:xfrm>
-          <a:prstGeom prst="rect">
-            <a:avLst/>
-          </a:prstGeom>
-          <a:noFill/>
-        </p:spPr>
-        <p:txBody>
-          <a:bodyPr wrap="square">
-            <a:spAutoFit/>
-          </a:bodyPr>
-          <a:lstStyle/>
-          <a:p>
-            <a:pPr>
-              <a:defRPr sz="1800" b="0">
-                <a:solidFill>
-                  <a:srgbClr val="9E95A7"/>
-                </a:solidFill>
-                <a:latin typeface="Arial"/>
-              </a:defRPr>
-            </a:pPr>
-            <a:r>
-              <a:t>Scan to connect</a:t>
-            </a:r>
-          </a:p>
-        </p:txBody>
-      </p:sp>
-      <p:sp>
-        <p:nvSpPr>
-          <p:cNvPr id="5" name="TextBox 4"/>
-          <p:cNvSpPr txBox="1"/>
-          <p:nvPr/>
-        </p:nvSpPr>
-        <p:spPr>
-          <a:xfrm>
-            <a:off x="4572000" y="5029200"/>
-            <a:ext cx="2743200" cy="457200"/>
-          </a:xfrm>
-          <a:prstGeom prst="rect">
-            <a:avLst/>
-          </a:prstGeom>
-          <a:noFill/>
-        </p:spPr>
-        <p:txBody>
-          <a:bodyPr wrap="square">
-            <a:spAutoFit/>
-          </a:bodyPr>
-          <a:lstStyle/>
-          <a:p>
-            <a:pPr>
-              <a:defRPr sz="2400" b="0">
-                <a:solidFill>
-                  <a:srgbClr val="6B5F78"/>
-                </a:solidFill>
-                <a:latin typeface="Arial"/>
-              </a:defRPr>
-            </a:pPr>
-            <a:r>
-              <a:t>[QR CODE]</a:t>
-            </a:r>
-          </a:p>
-        </p:txBody>
-      </p:sp>
-      <p:sp>
-        <p:nvSpPr>
-          <p:cNvPr id="6" name="TextBox 5"/>
-          <p:cNvSpPr txBox="1"/>
-          <p:nvPr/>
-        </p:nvSpPr>
-        <p:spPr>
-          <a:xfrm>
-            <a:off x="5029200" y="5943600"/>
-            <a:ext cx="1828800" cy="457200"/>
-          </a:xfrm>
-          <a:prstGeom prst="rect">
-            <a:avLst/>
-          </a:prstGeom>
-          <a:noFill/>
-        </p:spPr>
-        <p:txBody>
-          <a:bodyPr wrap="square">
-            <a:spAutoFit/>
-          </a:bodyPr>
-          <a:lstStyle/>
-          <a:p>
-            <a:pPr>
-              <a:defRPr sz="1800" b="1">
-                <a:solidFill>
-                  <a:srgbClr val="D4CED9"/>
-                </a:solidFill>
-                <a:latin typeface="Arial"/>
-              </a:defRPr>
-            </a:pPr>
-            <a:r>
-              <a:t>@accesly</a:t>
-            </a:r>
-          </a:p>
-        </p:txBody>
-      </p:sp>
+      </p:pic>
     </p:spTree>
   </p:cSld>
   <p:clrMapOvr>

</xml_diff>